<commit_message>
feat(ppt): 动画/切换标记 + 图表/SmartArt 占位 + e2e 接入 CI
- pptx.rs:graphicFrame → placeholder_kind(chart/diagram/table)、
  timing/transition → has_animation/has_transition;补单测
- web/ppt:slideRender 旋转仿射 + 图表/SmartArt 虚线占位框+标签,
  PptPage 动画/切换徽标;model 增字段;slideRender 单测
- e2e:fixture 第二张幻灯加旋转矩形+图表+切换/动画,ppt.spec 断言徽标
- CI:ci.yml 新增 e2e job(wasm-pack + fixtures + playwright chromium)
- 文档:RFC-0006/architecture/AGENTS/README 同步,新增报告-0008

Co-Authored-By: Claude Opus 4.8 <noreply@anthropic.com>
</commit_message>
<xml_diff>
--- a/web/e2e/fixtures/sample.pptx
+++ b/web/e2e/fixtures/sample.pptx
@@ -95,33 +95,32 @@
       </p:sp>
       <p:sp>
         <p:spPr>
-          <a:xfrm>
+          <a:xfrm rot="2700000">
             <a:off x="838200" y="1800000"/>
-            <a:ext cx="7772400" cy="2000000"/>
+            <a:ext cx="2200000" cy="1200000"/>
           </a:xfrm>
-        </p:spPr>
-        <p:txBody>
-          <a:p>
-            <a:r>
-              <a:rPr sz="2000"/>
-              <a:t>居中标题 + 椭圆形状,演示模式可翻页</a:t>
-            </a:r>
-          </a:p>
-        </p:txBody>
-      </p:sp>
-      <p:sp>
-        <p:spPr>
-          <a:xfrm>
-            <a:off x="5000000" y="2500000"/>
-            <a:ext cx="2500000" cy="1500000"/>
-          </a:xfrm>
-          <a:prstGeom prst="ellipse"/>
+          <a:prstGeom prst="rect"/>
           <a:solidFill>
             <a:srgbClr val="4472C4"/>
           </a:solidFill>
         </p:spPr>
       </p:sp>
+      <p:graphicFrame>
+        <p:xfrm>
+          <a:off x="4200000" y="1800000"/>
+          <a:ext cx="3500000" cy="2600000"/>
+        </p:xfrm>
+        <a:graphic>
+          <a:graphicData uri="http://schemas.openxmlformats.org/drawingml/2006/chart"/>
+        </a:graphic>
+      </p:graphicFrame>
     </p:spTree>
   </p:cSld>
+  <p:transition>
+    <p:fade/>
+  </p:transition>
+  <p:timing>
+    <p:tnLst/>
+  </p:timing>
 </p:sld>
 </file>
</xml_diff>